<commit_message>
docs(deliverables): center the project question
</commit_message>
<xml_diff>
--- a/docs/apresentacao/apresentacao_rota_em_dia.pptx
+++ b/docs/apresentacao/apresentacao_rota_em_dia.pptx
@@ -5044,7 +5044,7 @@
               </a:defRPr>
             </a:pPr>
             <a:r>
-              <a:t>O Problema</a:t>
+              <a:t>Problema e Pergunta Central</a:t>
             </a:r>
           </a:p>
         </p:txBody>
@@ -5058,7 +5058,7 @@
         <p:spPr>
           <a:xfrm>
             <a:off x="658368" y="1115568"/>
-            <a:ext cx="6720840" cy="2971800"/>
+            <a:ext cx="6720840" cy="3200400"/>
           </a:xfrm>
           <a:prstGeom prst="roundRect">
             <a:avLst>
@@ -5102,8 +5102,8 @@
         </p:nvSpPr>
         <p:spPr>
           <a:xfrm>
-            <a:off x="987552" y="1572768"/>
-            <a:ext cx="6080760" cy="1024128"/>
+            <a:off x="987552" y="1371600"/>
+            <a:ext cx="6080760" cy="603504"/>
           </a:xfrm>
           <a:prstGeom prst="rect">
             <a:avLst/>
@@ -5117,7 +5117,7 @@
           <a:lstStyle/>
           <a:p>
             <a:pPr algn="l">
-              <a:defRPr sz="2400" b="1">
+              <a:defRPr sz="1600" b="1">
                 <a:solidFill>
                   <a:srgbClr val="005A67"/>
                 </a:solidFill>
@@ -5138,8 +5138,8 @@
         </p:nvSpPr>
         <p:spPr>
           <a:xfrm>
-            <a:off x="987552" y="2907792"/>
-            <a:ext cx="5943600" cy="804672"/>
+            <a:off x="987552" y="2084831"/>
+            <a:ext cx="5943600" cy="274320"/>
           </a:xfrm>
           <a:prstGeom prst="rect">
             <a:avLst/>
@@ -5153,22 +5153,58 @@
           <a:lstStyle/>
           <a:p>
             <a:pPr algn="l">
-              <a:defRPr sz="1600" b="0">
-                <a:solidFill>
-                  <a:srgbClr val="17343A"/>
-                </a:solidFill>
-                <a:latin typeface="Noto Sans"/>
-              </a:defRPr>
-            </a:pPr>
-            <a:r>
-              <a:t>O RH precisa saber se a piora é geral, onde ela se concentra e qual explicação os dados realmente sustentam.</a:t>
-            </a:r>
-          </a:p>
-        </p:txBody>
-      </p:sp>
-      <p:sp>
-        <p:nvSpPr>
-          <p:cNvPr id="11" name="Rounded Rectangle 10"/>
+              <a:defRPr sz="1200" b="1">
+                <a:solidFill>
+                  <a:srgbClr val="F06449"/>
+                </a:solidFill>
+                <a:latin typeface="Noto Sans"/>
+              </a:defRPr>
+            </a:pPr>
+            <a:r>
+              <a:t>PERGUNTA CENTRAL</a:t>
+            </a:r>
+          </a:p>
+        </p:txBody>
+      </p:sp>
+      <p:sp>
+        <p:nvSpPr>
+          <p:cNvPr id="11" name="TextBox 10"/>
+          <p:cNvSpPr txBox="1"/>
+          <p:nvPr/>
+        </p:nvSpPr>
+        <p:spPr>
+          <a:xfrm>
+            <a:off x="987552" y="2423160"/>
+            <a:ext cx="5989320" cy="1444752"/>
+          </a:xfrm>
+          <a:prstGeom prst="rect">
+            <a:avLst/>
+          </a:prstGeom>
+          <a:noFill/>
+        </p:spPr>
+        <p:txBody>
+          <a:bodyPr wrap="square" lIns="36576" rIns="36576" tIns="36576" bIns="36576" anchor="t">
+            <a:spAutoFit/>
+          </a:bodyPr>
+          <a:lstStyle/>
+          <a:p>
+            <a:pPr algn="l">
+              <a:defRPr sz="2000" b="1">
+                <a:solidFill>
+                  <a:srgbClr val="005A67"/>
+                </a:solidFill>
+                <a:latin typeface="Noto Sans"/>
+              </a:defRPr>
+            </a:pPr>
+            <a:r>
+              <a:t>Por que os atrasos do transporte fretado aumentaram, onde se concentram e quais evidências sustentam a explicação mais plausível?</a:t>
+            </a:r>
+          </a:p>
+        </p:txBody>
+      </p:sp>
+      <p:sp>
+        <p:nvSpPr>
+          <p:cNvPr id="12" name="Rounded Rectangle 11"/>
           <p:cNvSpPr/>
           <p:nvPr/>
         </p:nvSpPr>
@@ -5213,7 +5249,7 @@
       </p:sp>
       <p:sp>
         <p:nvSpPr>
-          <p:cNvPr id="12" name="TextBox 11"/>
+          <p:cNvPr id="13" name="TextBox 12"/>
           <p:cNvSpPr txBox="1"/>
           <p:nvPr/>
         </p:nvSpPr>
@@ -5249,7 +5285,7 @@
       </p:sp>
       <p:sp>
         <p:nvSpPr>
-          <p:cNvPr id="13" name="TextBox 12"/>
+          <p:cNvPr id="14" name="TextBox 13"/>
           <p:cNvSpPr txBox="1"/>
           <p:nvPr/>
         </p:nvSpPr>
@@ -5285,7 +5321,7 @@
       </p:sp>
       <p:sp>
         <p:nvSpPr>
-          <p:cNvPr id="14" name="Rounded Rectangle 13"/>
+          <p:cNvPr id="15" name="Rounded Rectangle 14"/>
           <p:cNvSpPr/>
           <p:nvPr/>
         </p:nvSpPr>
@@ -5330,7 +5366,7 @@
       </p:sp>
       <p:sp>
         <p:nvSpPr>
-          <p:cNvPr id="15" name="TextBox 14"/>
+          <p:cNvPr id="16" name="TextBox 15"/>
           <p:cNvSpPr txBox="1"/>
           <p:nvPr/>
         </p:nvSpPr>
@@ -5366,7 +5402,7 @@
       </p:sp>
       <p:sp>
         <p:nvSpPr>
-          <p:cNvPr id="16" name="TextBox 15"/>
+          <p:cNvPr id="17" name="TextBox 16"/>
           <p:cNvSpPr txBox="1"/>
           <p:nvPr/>
         </p:nvSpPr>
@@ -5402,7 +5438,7 @@
       </p:sp>
       <p:sp>
         <p:nvSpPr>
-          <p:cNvPr id="17" name="Rounded Rectangle 16"/>
+          <p:cNvPr id="18" name="Rounded Rectangle 17"/>
           <p:cNvSpPr/>
           <p:nvPr/>
         </p:nvSpPr>
@@ -5447,7 +5483,7 @@
       </p:sp>
       <p:sp>
         <p:nvSpPr>
-          <p:cNvPr id="18" name="TextBox 17"/>
+          <p:cNvPr id="19" name="TextBox 18"/>
           <p:cNvSpPr txBox="1"/>
           <p:nvPr/>
         </p:nvSpPr>
@@ -5483,7 +5519,7 @@
       </p:sp>
       <p:sp>
         <p:nvSpPr>
-          <p:cNvPr id="19" name="TextBox 18"/>
+          <p:cNvPr id="20" name="TextBox 19"/>
           <p:cNvSpPr txBox="1"/>
           <p:nvPr/>
         </p:nvSpPr>
@@ -5519,7 +5555,7 @@
       </p:sp>
       <p:sp>
         <p:nvSpPr>
-          <p:cNvPr id="20" name="Rounded Rectangle 19"/>
+          <p:cNvPr id="21" name="Rounded Rectangle 20"/>
           <p:cNvSpPr/>
           <p:nvPr/>
         </p:nvSpPr>
@@ -5564,7 +5600,7 @@
       </p:sp>
       <p:sp>
         <p:nvSpPr>
-          <p:cNvPr id="21" name="TextBox 20"/>
+          <p:cNvPr id="22" name="TextBox 21"/>
           <p:cNvSpPr txBox="1"/>
           <p:nvPr/>
         </p:nvSpPr>
@@ -5600,7 +5636,7 @@
       </p:sp>
       <p:sp>
         <p:nvSpPr>
-          <p:cNvPr id="22" name="TextBox 21"/>
+          <p:cNvPr id="23" name="TextBox 22"/>
           <p:cNvSpPr txBox="1"/>
           <p:nvPr/>
         </p:nvSpPr>
@@ -5636,7 +5672,7 @@
       </p:sp>
       <p:sp>
         <p:nvSpPr>
-          <p:cNvPr id="23" name="TextBox 22"/>
+          <p:cNvPr id="24" name="TextBox 23"/>
           <p:cNvSpPr txBox="1"/>
           <p:nvPr/>
         </p:nvSpPr>
@@ -5672,7 +5708,7 @@
       </p:sp>
       <p:sp>
         <p:nvSpPr>
-          <p:cNvPr id="24" name="TextBox 23"/>
+          <p:cNvPr id="25" name="TextBox 24"/>
           <p:cNvSpPr txBox="1"/>
           <p:nvPr/>
         </p:nvSpPr>
@@ -5708,7 +5744,7 @@
       </p:sp>
       <p:sp>
         <p:nvSpPr>
-          <p:cNvPr id="25" name="TextBox 24"/>
+          <p:cNvPr id="26" name="TextBox 25"/>
           <p:cNvSpPr txBox="1"/>
           <p:nvPr/>
         </p:nvSpPr>
@@ -6007,7 +6043,7 @@
               </a:defRPr>
             </a:pPr>
             <a:r>
-              <a:t>Perguntas e Hipóteses</a:t>
+              <a:t>Hipóteses Para Responder</a:t>
             </a:r>
           </a:p>
         </p:txBody>
@@ -6088,7 +6124,7 @@
               </a:defRPr>
             </a:pPr>
             <a:r>
-              <a:t>A queda é geral por causa da chuva ou está concentrada em rotas, turnos e períodos específicos?</a:t>
+              <a:t>Testamos três explicações concorrentes para responder por que os atrasos aumentaram.</a:t>
             </a:r>
           </a:p>
         </p:txBody>
@@ -6691,7 +6727,7 @@
               </a:defRPr>
             </a:pPr>
             <a:r>
-              <a:t>Não buscamos uma resposta escondida. Construímos a explicação mais defensável.</a:t>
+              <a:t>Cada hipótese foi confrontada com evidências, comparações e limitações.</a:t>
             </a:r>
           </a:p>
         </p:txBody>
@@ -8939,7 +8975,7 @@
               </a:defRPr>
             </a:pPr>
             <a:r>
-              <a:t>Evidências e Conclusão</a:t>
+              <a:t>Resposta à Pergunta Central</a:t>
             </a:r>
           </a:p>
         </p:txBody>
@@ -9044,7 +9080,7 @@
               </a:defRPr>
             </a:pPr>
             <a:r>
-              <a:t>Chuva Agrava</a:t>
+              <a:t>Onde?</a:t>
             </a:r>
           </a:p>
         </p:txBody>
@@ -9080,7 +9116,7 @@
               </a:defRPr>
             </a:pPr>
             <a:r>
-              <a:t>Correlação moderada, mas o efeito aparece em toda a operação.</a:t>
+              <a:t>R03 e R05, nos turnos da manhã e tarde, desde 06/04.</a:t>
             </a:r>
           </a:p>
         </p:txBody>
@@ -9161,7 +9197,7 @@
               </a:defRPr>
             </a:pPr>
             <a:r>
-              <a:t>Obra Localiza</a:t>
+              <a:t>Por quê?</a:t>
             </a:r>
           </a:p>
         </p:txBody>
@@ -9197,7 +9233,7 @@
               </a:defRPr>
             </a:pPr>
             <a:r>
-              <a:t>“Obra na via” surge em 07/04 somente em R03 e R05.</a:t>
+              <a:t>Restrição diurna no corredor é a explicação mais plausível.</a:t>
             </a:r>
           </a:p>
         </p:txBody>
@@ -9278,7 +9314,7 @@
               </a:defRPr>
             </a:pPr>
             <a:r>
-              <a:t>Noite Preserva</a:t>
+              <a:t>Evidências</a:t>
             </a:r>
           </a:p>
         </p:txBody>
@@ -9314,7 +9350,7 @@
               </a:defRPr>
             </a:pPr>
             <a:r>
-              <a:t>As duas rotas mantêm 96% de pontualidade no turno noturno.</a:t>
+              <a:t>Média móvel, heatmap, distribuição, chuva controlada e registros de obra.</a:t>
             </a:r>
           </a:p>
         </p:txBody>
@@ -9387,7 +9423,7 @@
           <a:lstStyle/>
           <a:p>
             <a:pPr algn="ctr">
-              <a:defRPr sz="1600" b="1">
+              <a:defRPr sz="1500" b="1">
                 <a:solidFill>
                   <a:srgbClr val="FFF8E8"/>
                 </a:solidFill>
@@ -9395,7 +9431,7 @@
               </a:defRPr>
             </a:pPr>
             <a:r>
-              <a:t>Hipótese mais plausível: restrição diurna no corredor compartilhado.</a:t>
+              <a:t>A resposta ainda precisa de confirmação com GPS e cronogramas de obra.</a:t>
             </a:r>
           </a:p>
         </p:txBody>

</xml_diff>